<commit_message>
Present final traffic results and coverage; correct Kai-Chun Chang acknowledgement
Replace recording-map comparisons with the 22-case results, final R3/R5
comparison and peak-range coverage. Update the poster, figures, abstract
and contribution/disclosure statements.
</commit_message>
<xml_diff>
--- a/poster/VBI_research_poster.pptx
+++ b/poster/VBI_research_poster.pptx
@@ -2,13 +2,13 @@
 <file path=ppt/presentation.xml><?xml version="1.0" encoding="utf-8"?>
 <p:presentation xmlns:p="http://schemas.openxmlformats.org/presentationml/2006/main">
   <p:sldMasterIdLst>
-    <p:sldMasterId xmlns:r="http://schemas.openxmlformats.org/officeDocument/2006/relationships" id="2147483648" r:id="R0ddf045599af4293"/>
+    <p:sldMasterId xmlns:r="http://schemas.openxmlformats.org/officeDocument/2006/relationships" id="2147483648" r:id="Rd73bd28226974d21"/>
   </p:sldMasterIdLst>
   <p:notesMasterIdLst>
-    <p:notesMasterId xmlns:r="http://schemas.openxmlformats.org/officeDocument/2006/relationships" r:id="R710614110eb74a1c"/>
+    <p:notesMasterId xmlns:r="http://schemas.openxmlformats.org/officeDocument/2006/relationships" r:id="R1a22fde77ddc4359"/>
   </p:notesMasterIdLst>
   <p:sldIdLst>
-    <p:sldId xmlns:r="http://schemas.openxmlformats.org/officeDocument/2006/relationships" id="256" r:id="R1cc7e89b66524857"/>
+    <p:sldId xmlns:r="http://schemas.openxmlformats.org/officeDocument/2006/relationships" id="256" r:id="R87ef4927cd6a4efc"/>
   </p:sldIdLst>
   <p:sldSz cx="15120000" cy="10692000"/>
   <p:notesSz cx="6858000" cy="9144000"/>
@@ -442,7 +442,7 @@
           <a:lstStyle xmlns:a="http://schemas.openxmlformats.org/drawingml/2006/main"/>
           <a:p xmlns:a="http://schemas.openxmlformats.org/drawingml/2006/main">
             <a:r>
-              <a:t>Sources: completed-result audit (16 October 2026), common expanded-map stress-cycle analysis (23 October 2026), and section-mapping verification (26 October 2026). The sampling comparison uses nominal uncracked gross-section bending stress and I3=sum n_i*(Delta sigma_i/1 MPa)^3. It is a historical sampling-method result, separate from later reinforcement-aware recovery. Ratios compare case-wise maxima over fixed probes; they do not compare an identical control point. The presentation contains newly written explanations and aggregate derived values, without private source code or original drawings.</a:t>
+              <a:t>Sources: final 22-case nominal concrete stress-cycle screening and peak-range coverage summary, October 2026. The displayed 40 m reference-spacing cases use a matched passage-duration comparison. Rm is the ratio of case-wise maximum fixed-probe cumulative indices to the two-lane reference. The numerator and denominator may control at different locations. Minimum longitudinal/transverse peak-range coverage across all selected cases is 0.9553191368105968. The nominal stress screening uses uncracked gross-section recovery, separate from the section-recovery implementation checks. Professor Kai-Chun Chang provided the bridge drawings and reference materials. No private framework source code, source drawings or raw results are embedded.</a:t>
             </a:r>
           </a:p>
         </p:txBody>
@@ -2885,12 +2885,12 @@
   </p:cSld>
   <p:clrMap bg1="lt1" tx1="dk1" bg2="lt2" tx2="dk2" accent1="accent1" accent2="accent2" accent3="accent3" accent4="accent4" accent5="accent5" accent6="accent6" hlink="hlink" folHlink="folHlink"/>
   <p:sldLayoutIdLst>
-    <p:sldLayoutId xmlns:r="http://schemas.openxmlformats.org/officeDocument/2006/relationships" id="2147483649" r:id="Rae8206335e2042a3"/>
-    <p:sldLayoutId xmlns:r="http://schemas.openxmlformats.org/officeDocument/2006/relationships" id="2147483650" r:id="R8ea5ff4564634704"/>
-    <p:sldLayoutId xmlns:r="http://schemas.openxmlformats.org/officeDocument/2006/relationships" id="2147483651" r:id="Re8e8e19fbbc8455e"/>
-    <p:sldLayoutId xmlns:r="http://schemas.openxmlformats.org/officeDocument/2006/relationships" id="2147483652" r:id="R6d26cdba3eae49e1"/>
-    <p:sldLayoutId xmlns:r="http://schemas.openxmlformats.org/officeDocument/2006/relationships" id="2147483653" r:id="R222fd437a2c44667"/>
-    <p:sldLayoutId xmlns:r="http://schemas.openxmlformats.org/officeDocument/2006/relationships" id="2147483654" r:id="R7e3afa128378400c"/>
+    <p:sldLayoutId xmlns:r="http://schemas.openxmlformats.org/officeDocument/2006/relationships" id="2147483649" r:id="Rcbdbd256160d4b3e"/>
+    <p:sldLayoutId xmlns:r="http://schemas.openxmlformats.org/officeDocument/2006/relationships" id="2147483650" r:id="Rcb032af800a743e0"/>
+    <p:sldLayoutId xmlns:r="http://schemas.openxmlformats.org/officeDocument/2006/relationships" id="2147483651" r:id="R9d1d5501723c4fde"/>
+    <p:sldLayoutId xmlns:r="http://schemas.openxmlformats.org/officeDocument/2006/relationships" id="2147483652" r:id="Rc4b19b37a7da4cda"/>
+    <p:sldLayoutId xmlns:r="http://schemas.openxmlformats.org/officeDocument/2006/relationships" id="2147483653" r:id="R0c34d17cd89b4c11"/>
+    <p:sldLayoutId xmlns:r="http://schemas.openxmlformats.org/officeDocument/2006/relationships" id="2147483654" r:id="R208547592d414de0"/>
   </p:sldLayoutIdLst>
   <p:txStyles>
     <p:titleStyle>
@@ -3430,51 +3430,57 @@
           <c:idx val="0"/>
           <c:order val="0"/>
           <c:tx>
-            <c:v>Original map (61)</c:v>
+            <c:v>R3</c:v>
           </c:tx>
           <c:spPr>
             <a:solidFill xmlns:a="http://schemas.openxmlformats.org/drawingml/2006/main">
-              <a:srgbClr val="BEC7CF"/>
+              <a:srgbClr val="132B40"/>
             </a:solidFill>
           </c:spPr>
           <c:invertIfNegative val="0"/>
           <c:cat>
             <c:strRef>
-              <c:f>'Chart Data'!$A$2:$A$5</c:f>
+              <c:f>'Chart Data'!$A$2:$A$6</c:f>
               <c:strCache>
-                <c:ptCount val="4"/>
+                <c:ptCount val="5"/>
                 <c:pt idx="0">
-                  <c:v>30 m</c:v>
+                  <c:v>Two-lane</c:v>
                 </c:pt>
                 <c:pt idx="1">
-                  <c:v>40 m</c:v>
+                  <c:v>Sᵧ 0.05</c:v>
                 </c:pt>
                 <c:pt idx="2">
-                  <c:v>60 m</c:v>
+                  <c:v>Sᵧ 0.10</c:v>
                 </c:pt>
                 <c:pt idx="3">
-                  <c:v>115 m</c:v>
+                  <c:v>Sᵧ 0.15</c:v>
+                </c:pt>
+                <c:pt idx="4">
+                  <c:v>Grouped</c:v>
                 </c:pt>
               </c:strCache>
             </c:strRef>
           </c:cat>
           <c:val>
             <c:numRef>
-              <c:f>'Chart Data'!$B$2:$B$5</c:f>
+              <c:f>'Chart Data'!$B$2:$B$6</c:f>
               <c:numCache>
                 <c:formatCode>0</c:formatCode>
-                <c:ptCount val="4"/>
+                <c:ptCount val="5"/>
                 <c:pt idx="0">
-                  <c:v>11.614416</c:v>
+                  <c:v>1</c:v>
                 </c:pt>
                 <c:pt idx="1">
-                  <c:v>11.806526</c:v>
+                  <c:v>1.790525</c:v>
                 </c:pt>
                 <c:pt idx="2">
-                  <c:v>11.775953</c:v>
+                  <c:v>1.077521</c:v>
                 </c:pt>
                 <c:pt idx="3">
-                  <c:v>11.761526</c:v>
+                  <c:v>0.679234</c:v>
+                </c:pt>
+                <c:pt idx="4">
+                  <c:v>1.664541</c:v>
                 </c:pt>
               </c:numCache>
             </c:numRef>
@@ -3484,7 +3490,7 @@
           <c:idx val="1"/>
           <c:order val="1"/>
           <c:tx>
-            <c:v>Expanded map (109)</c:v>
+            <c:v>R5</c:v>
           </c:tx>
           <c:spPr>
             <a:solidFill xmlns:a="http://schemas.openxmlformats.org/drawingml/2006/main">
@@ -3494,41 +3500,47 @@
           <c:invertIfNegative val="0"/>
           <c:cat>
             <c:strRef>
-              <c:f>'Chart Data'!$C$2:$C$5</c:f>
+              <c:f>'Chart Data'!$C$2:$C$6</c:f>
               <c:strCache>
-                <c:ptCount val="4"/>
+                <c:ptCount val="5"/>
                 <c:pt idx="0">
-                  <c:v>30 m</c:v>
+                  <c:v>Two-lane</c:v>
                 </c:pt>
                 <c:pt idx="1">
-                  <c:v>40 m</c:v>
+                  <c:v>Sᵧ 0.05</c:v>
                 </c:pt>
                 <c:pt idx="2">
-                  <c:v>60 m</c:v>
+                  <c:v>Sᵧ 0.10</c:v>
                 </c:pt>
                 <c:pt idx="3">
-                  <c:v>115 m</c:v>
+                  <c:v>Sᵧ 0.15</c:v>
+                </c:pt>
+                <c:pt idx="4">
+                  <c:v>Grouped</c:v>
                 </c:pt>
               </c:strCache>
             </c:strRef>
           </c:cat>
           <c:val>
             <c:numRef>
-              <c:f>'Chart Data'!$D$2:$D$5</c:f>
+              <c:f>'Chart Data'!$D$2:$D$6</c:f>
               <c:numCache>
                 <c:formatCode>0</c:formatCode>
-                <c:ptCount val="4"/>
+                <c:ptCount val="5"/>
                 <c:pt idx="0">
-                  <c:v>1.762181</c:v>
+                  <c:v>1</c:v>
                 </c:pt>
                 <c:pt idx="1">
-                  <c:v>1.790525</c:v>
+                  <c:v>2.666752</c:v>
                 </c:pt>
                 <c:pt idx="2">
-                  <c:v>1.786359</c:v>
+                  <c:v>1.54677</c:v>
                 </c:pt>
                 <c:pt idx="3">
-                  <c:v>1.784601</c:v>
+                  <c:v>1.556537</c:v>
+                </c:pt>
+                <c:pt idx="4">
+                  <c:v>4.228691</c:v>
                 </c:pt>
               </c:numCache>
             </c:numRef>
@@ -3541,7 +3553,7 @@
             <a:lstStyle xmlns:a="http://schemas.openxmlformats.org/drawingml/2006/main"/>
             <a:p xmlns:a="http://schemas.openxmlformats.org/drawingml/2006/main">
               <a:pPr>
-                <a:defRPr sz="1124">
+                <a:defRPr sz="1050">
                   <a:solidFill>
                     <a:srgbClr val="243746"/>
                   </a:solidFill>
@@ -3558,7 +3570,7 @@
           <c:showBubbleSize val="0"/>
           <c:showLeaderLines val="0"/>
         </c:dLbls>
-        <c:gapWidth val="130"/>
+        <c:gapWidth val="110"/>
         <c:axId val="48650112"/>
         <c:axId val="48672768"/>
       </c:barChart>
@@ -3584,7 +3596,7 @@
           <a:lstStyle xmlns:a="http://schemas.openxmlformats.org/drawingml/2006/main"/>
           <a:p xmlns:a="http://schemas.openxmlformats.org/drawingml/2006/main">
             <a:pPr>
-              <a:defRPr sz="1257">
+              <a:defRPr sz="1050">
                 <a:solidFill>
                   <a:srgbClr val="243746"/>
                 </a:solidFill>
@@ -3598,7 +3610,7 @@
         <c:axId val="48672768"/>
         <c:scaling>
           <c:orientation val="minMax"/>
-          <c:max val="14"/>
+          <c:max val="5"/>
           <c:min val="0"/>
         </c:scaling>
         <c:delete val="0"/>
@@ -3628,7 +3640,7 @@
           <a:lstStyle xmlns:a="http://schemas.openxmlformats.org/drawingml/2006/main"/>
           <a:p xmlns:a="http://schemas.openxmlformats.org/drawingml/2006/main">
             <a:pPr>
-              <a:defRPr sz="1191">
+              <a:defRPr sz="1200">
                 <a:solidFill>
                   <a:srgbClr val="5D6B78"/>
                 </a:solidFill>
@@ -3638,7 +3650,7 @@
         </c:txPr>
         <c:crossAx val="48650112"/>
         <c:crossBetween val="between"/>
-        <c:majorUnit val="4"/>
+        <c:majorUnit val="1"/>
       </c:valAx>
       <c:spPr>
         <a:solidFill xmlns:a="http://schemas.openxmlformats.org/drawingml/2006/main">
@@ -3654,7 +3666,7 @@
         <a:lstStyle xmlns:a="http://schemas.openxmlformats.org/drawingml/2006/main"/>
         <a:p xmlns:a="http://schemas.openxmlformats.org/drawingml/2006/main">
           <a:pPr>
-            <a:defRPr sz="1191">
+            <a:defRPr sz="1200">
               <a:solidFill>
                 <a:srgbClr val="243746"/>
               </a:solidFill>
@@ -4164,7 +4176,7 @@
                 <a:ea typeface="Arial"/>
                 <a:cs typeface="Arial"/>
               </a:rPr>
-              <a:t>Vehicle–bridge interaction, spatial sampling and stress-cycle screening</a:t>
+              <a:t>Traffic organization and nominal concrete stress cycles</a:t>
             </a:r>
           </a:p>
         </p:txBody>
@@ -4719,7 +4731,7 @@
                 <a:ea typeface="Arial"/>
                 <a:cs typeface="Arial"/>
               </a:rPr>
-              <a:t>How does traffic organization change deck response when the vehicle fleet stays fixed, and how reliably do saved locations capture local cycle demand?</a:t>
+              <a:t>How does traffic organization affect local deck stress-cycle demand when the vehicle fleet stays fixed?</a:t>
             </a:r>
           </a:p>
         </p:txBody>
@@ -5957,7 +5969,7 @@
                 <a:ea typeface="Arial"/>
                 <a:cs typeface="Arial"/>
               </a:rPr>
-              <a:t>Spatial sampling sensitivity</a:t>
+              <a:t>Traffic comparison</a:t>
             </a:r>
           </a:p>
         </p:txBody>
@@ -6144,7 +6156,7 @@
                 <a:ea typeface="Arial"/>
                 <a:cs typeface="Arial"/>
               </a:rPr>
-              <a:t>Five cases share an expanded recording map: 61 to 109 interior locations. Additional-output reruns reproduce every original moment history with zero difference.</a:t>
+              <a:t>At d = 40 m, the fleet and passage duration match across the displayed protocols. Ratios compare maximum fixed-channel indices to two-lane traffic.</a:t>
             </a:r>
           </a:p>
         </p:txBody>
@@ -6302,36 +6314,14 @@
                 <a:ea typeface="Arial"/>
                 <a:cs typeface="Arial"/>
               </a:rPr>
-              <a:t>Gross-section nominal stress: maximum I₃ ratio</a:t>
+              <a:t>Relative cumulative index (two-lane = 1)</a:t>
             </a:r>
           </a:p>
         </p:txBody>
       </p:sp>
-      <p:graphicFrame>
-        <p:nvGraphicFramePr>
-          <p:cNvPr id="22" name="Chart">
-            <a:extLst xmlns:a="http://schemas.openxmlformats.org/drawingml/2006/main">
-              <a:ext uri="{FF2B5EF4-FFF2-40B4-BE49-F238E27FC236}">
-                <a16:creationId xmlns:a16="http://schemas.microsoft.com/office/drawing/2014/main" id="{14F65896-94C6-4A5C-9C67-90541D481E65}"/>
-              </a:ext>
-            </a:extLst>
-          </p:cNvPr>
-          <p:cNvGraphicFramePr/>
-          <p:nvPr/>
-        </p:nvGraphicFramePr>
-        <p:xfrm>
-          <a:off xmlns:a="http://schemas.openxmlformats.org/drawingml/2006/main" x="5166000" y="4645200"/>
-          <a:ext xmlns:a="http://schemas.openxmlformats.org/drawingml/2006/main" cx="4746000" cy="2688000"/>
-        </p:xfrm>
-        <a:graphic xmlns:a="http://schemas.openxmlformats.org/drawingml/2006/main">
-          <a:graphicData uri="http://schemas.openxmlformats.org/drawingml/2006/chart">
-            <c:chart xmlns:r="http://schemas.openxmlformats.org/officeDocument/2006/relationships" xmlns:c="http://schemas.openxmlformats.org/drawingml/2006/chart" r:id="Rd81f71b0a1a9495b"/>
-          </a:graphicData>
-        </a:graphic>
-      </p:graphicFrame>
       <p:sp>
         <p:nvSpPr>
-          <p:cNvPr id="23" name="sampling-caption">
+          <p:cNvPr id="22" name="sampling-caption">
             <a:extLst xmlns:a="http://schemas.openxmlformats.org/drawingml/2006/main">
               <a:ext uri="{FF2B5EF4-FFF2-40B4-BE49-F238E27FC236}">
                 <a16:creationId xmlns:a16="http://schemas.microsoft.com/office/drawing/2014/main" id="{FB1EC97E-9E82-4566-9511-EFE266AFA887}"/>
@@ -6482,14 +6472,14 @@
                 <a:ea typeface="Arial"/>
                 <a:cs typeface="Arial"/>
               </a:rPr>
-              <a:t>Four uniform-order cases at lateral spread Sᵧ = 0.05. Each ratio uses its own recording map for both the case and reference. Maxima can occur at different locations.</a:t>
+              <a:t>Spread cases use uniform vehicle ordering. The maxima refer to fixed probes and may occur at different locations. Grouping changes the overall traffic organization.</a:t>
             </a:r>
           </a:p>
         </p:txBody>
       </p:sp>
       <p:sp>
         <p:nvSpPr>
-          <p:cNvPr id="24" name="takeaway">
+          <p:cNvPr id="23" name="takeaway">
             <a:extLst xmlns:a="http://schemas.openxmlformats.org/drawingml/2006/main">
               <a:ext uri="{FF2B5EF4-FFF2-40B4-BE49-F238E27FC236}">
                 <a16:creationId xmlns:a16="http://schemas.microsoft.com/office/drawing/2014/main" id="{C7FB0A21-D2F4-44CA-9491-DB674C4815BA}"/>
@@ -6640,14 +6630,14 @@
                 <a:ea typeface="Arial"/>
                 <a:cs typeface="Arial"/>
               </a:rPr>
-              <a:t>1.76–1.79</a:t>
+              <a:t>95.53%</a:t>
             </a:r>
           </a:p>
         </p:txBody>
       </p:sp>
       <p:sp>
         <p:nvSpPr>
-          <p:cNvPr id="25" name="takeaway-description">
+          <p:cNvPr id="24" name="takeaway-description">
             <a:extLst xmlns:a="http://schemas.openxmlformats.org/drawingml/2006/main">
               <a:ext uri="{FF2B5EF4-FFF2-40B4-BE49-F238E27FC236}">
                 <a16:creationId xmlns:a16="http://schemas.microsoft.com/office/drawing/2014/main" id="{567776C1-DF88-4DA8-9986-A98502D33C21}"/>
@@ -6798,14 +6788,14 @@
                 <a:ea typeface="Arial"/>
                 <a:cs typeface="Arial"/>
               </a:rPr>
-              <a:t>Expanded-map I₃ ratios replace the original 11.6–11.8 values. Coverage of the reference matters.</a:t>
+              <a:t>Minimum peak-range coverage across all 22 traffic scenarios, using both normal-stress directions.</a:t>
             </a:r>
           </a:p>
         </p:txBody>
       </p:sp>
       <p:sp>
         <p:nvSpPr>
-          <p:cNvPr id="26" name="evidence">
+          <p:cNvPr id="25" name="evidence">
             <a:extLst xmlns:a="http://schemas.openxmlformats.org/drawingml/2006/main">
               <a:ext uri="{FF2B5EF4-FFF2-40B4-BE49-F238E27FC236}">
                 <a16:creationId xmlns:a16="http://schemas.microsoft.com/office/drawing/2014/main" id="{6B5AE229-DD0A-41F5-97E8-DF5CC5AEC89F}"/>
@@ -6956,14 +6946,14 @@
                 <a:ea typeface="Arial"/>
                 <a:cs typeface="Arial"/>
               </a:rPr>
-              <a:t>Numerical evidence</a:t>
+              <a:t>Response coverage</a:t>
             </a:r>
           </a:p>
         </p:txBody>
       </p:sp>
       <p:sp>
         <p:nvSpPr>
-          <p:cNvPr id="27" name="">
+          <p:cNvPr id="26" name="">
             <a:extLst xmlns:a="http://schemas.openxmlformats.org/drawingml/2006/main">
               <a:ext uri="{FF2B5EF4-FFF2-40B4-BE49-F238E27FC236}">
                 <a16:creationId xmlns:a16="http://schemas.microsoft.com/office/drawing/2014/main" id="{A253A422-00A6-45CE-9EA0-A96FAD67E07E}"/>
@@ -6992,7 +6982,7 @@
       </p:sp>
       <p:sp>
         <p:nvSpPr>
-          <p:cNvPr id="28" name="evidence-body">
+          <p:cNvPr id="27" name="evidence-body">
             <a:extLst xmlns:a="http://schemas.openxmlformats.org/drawingml/2006/main">
               <a:ext uri="{FF2B5EF4-FFF2-40B4-BE49-F238E27FC236}">
                 <a16:creationId xmlns:a16="http://schemas.microsoft.com/office/drawing/2014/main" id="{D3E81341-9596-45FB-9CEC-1A5DB3D495E2}"/>
@@ -7143,7 +7133,7 @@
                 <a:ea typeface="Arial"/>
                 <a:cs typeface="Arial"/>
               </a:rPr>
-              <a:t>20 initial cases passed completeness and contact-convergence audits. Iterations remained within the declared tolerance.</a:t>
+              <a:t>Coverage compares the largest saved rainflow range with the interior plate-field temporal range. The lower longitudinal/transverse ratio defines each case.</a:t>
             </a:r>
           </a:p>
           <a:p xmlns:a="http://schemas.openxmlformats.org/drawingml/2006/main">
@@ -7181,14 +7171,14 @@
                 <a:ea typeface="Arial"/>
                 <a:cs typeface="Arial"/>
               </a:rPr>
-              <a:t>Five recording-only reruns preserve all 213 original scalar histories.</a:t>
+              <a:t>All 22 cases reach at least 95.53%.</a:t>
             </a:r>
           </a:p>
         </p:txBody>
       </p:sp>
       <p:sp>
         <p:nvSpPr>
-          <p:cNvPr id="29" name="section">
+          <p:cNvPr id="28" name="section">
             <a:extLst xmlns:a="http://schemas.openxmlformats.org/drawingml/2006/main">
               <a:ext uri="{FF2B5EF4-FFF2-40B4-BE49-F238E27FC236}">
                 <a16:creationId xmlns:a16="http://schemas.microsoft.com/office/drawing/2014/main" id="{4A5E719C-06BA-41DC-8D99-4A0976508865}"/>
@@ -7339,14 +7329,14 @@
                 <a:ea typeface="Arial"/>
                 <a:cs typeface="Arial"/>
               </a:rPr>
-              <a:t>Section recovery extension</a:t>
+              <a:t>Section recovery</a:t>
             </a:r>
           </a:p>
         </p:txBody>
       </p:sp>
       <p:sp>
         <p:nvSpPr>
-          <p:cNvPr id="30" name="">
+          <p:cNvPr id="29" name="">
             <a:extLst xmlns:a="http://schemas.openxmlformats.org/drawingml/2006/main">
               <a:ext uri="{FF2B5EF4-FFF2-40B4-BE49-F238E27FC236}">
                 <a16:creationId xmlns:a16="http://schemas.microsoft.com/office/drawing/2014/main" id="{DF6B0DED-AA44-4E04-A54C-5BBC37A114AC}"/>
@@ -7375,7 +7365,7 @@
       </p:sp>
       <p:sp>
         <p:nvSpPr>
-          <p:cNvPr id="31" name="section-body">
+          <p:cNvPr id="30" name="section-body">
             <a:extLst xmlns:a="http://schemas.openxmlformats.org/drawingml/2006/main">
               <a:ext uri="{FF2B5EF4-FFF2-40B4-BE49-F238E27FC236}">
                 <a16:creationId xmlns:a16="http://schemas.microsoft.com/office/drawing/2014/main" id="{1D07F996-2BAB-448C-8851-4F45D17AE242}"/>
@@ -7526,10 +7516,20 @@
                 <a:ea typeface="Arial"/>
                 <a:cs typeface="Arial"/>
               </a:rPr>
-              <a:t>119 saved coordinates now have nominal reinforcement-section mappings.</a:t>
+              <a:t>Nominal reinforcement sections cover the saved observation coordinates.</a:t>
             </a:r>
           </a:p>
           <a:p xmlns:a="http://schemas.openxmlformats.org/drawingml/2006/main">
+            <a:pPr>
+              <a:defRPr sz="1587" b="0">
+                <a:solidFill>
+                  <a:srgbClr val="243746"/>
+                </a:solidFill>
+                <a:latin typeface="Arial"/>
+                <a:ea typeface="Arial"/>
+                <a:cs typeface="Arial"/>
+              </a:defRPr>
+            </a:pPr>
             <a:r>
               <a:t/>
             </a:r>
@@ -7561,7 +7561,7 @@
       </p:sp>
       <p:sp>
         <p:nvSpPr>
-          <p:cNvPr id="32" name="interpretation">
+          <p:cNvPr id="31" name="interpretation">
             <a:extLst xmlns:a="http://schemas.openxmlformats.org/drawingml/2006/main">
               <a:ext uri="{FF2B5EF4-FFF2-40B4-BE49-F238E27FC236}">
                 <a16:creationId xmlns:a16="http://schemas.microsoft.com/office/drawing/2014/main" id="{89E46074-24F0-4BC0-9D95-2FC759DE39C3}"/>
@@ -7712,14 +7712,14 @@
                 <a:ea typeface="Arial"/>
                 <a:cs typeface="Arial"/>
               </a:rPr>
-              <a:t>Interpretation and next steps</a:t>
+              <a:t>Interpretation</a:t>
             </a:r>
           </a:p>
         </p:txBody>
       </p:sp>
       <p:sp>
         <p:nvSpPr>
-          <p:cNvPr id="33" name="">
+          <p:cNvPr id="32" name="">
             <a:extLst xmlns:a="http://schemas.openxmlformats.org/drawingml/2006/main">
               <a:ext uri="{FF2B5EF4-FFF2-40B4-BE49-F238E27FC236}">
                 <a16:creationId xmlns:a16="http://schemas.microsoft.com/office/drawing/2014/main" id="{3D09BBA3-1751-422C-96D4-FEE2A75E4564}"/>
@@ -7748,7 +7748,7 @@
       </p:sp>
       <p:sp>
         <p:nvSpPr>
-          <p:cNvPr id="34" name="interpretation-body">
+          <p:cNvPr id="33" name="interpretation-body">
             <a:extLst xmlns:a="http://schemas.openxmlformats.org/drawingml/2006/main">
               <a:ext uri="{FF2B5EF4-FFF2-40B4-BE49-F238E27FC236}">
                 <a16:creationId xmlns:a16="http://schemas.microsoft.com/office/drawing/2014/main" id="{ED54C741-D5B2-4CA0-A8B6-29C1370EA4EC}"/>
@@ -7899,7 +7899,7 @@
                 <a:ea typeface="Arial"/>
                 <a:cs typeface="Arial"/>
               </a:rPr>
-              <a:t>I₃ = Σ nᵢ (Δσᵢ / 1 MPa)³</a:t>
+              <a:t>Rₘ = max Iₘ(case) / max Iₘ(reference)</a:t>
             </a:r>
           </a:p>
           <a:p xmlns:a="http://schemas.openxmlformats.org/drawingml/2006/main">
@@ -7914,7 +7914,7 @@
               </a:defRPr>
             </a:pPr>
             <a:r>
-              <a:t>This weights rainflow stress ranges for screening.</a:t>
+              <a:t>Iₘ = Σ nᵢ (Δσᵢ / 1 MPa)ᵐ</a:t>
             </a:r>
           </a:p>
           <a:p xmlns:a="http://schemas.openxmlformats.org/drawingml/2006/main">
@@ -7960,14 +7960,14 @@
                 <a:ea typeface="Arial"/>
                 <a:cs typeface="Arial"/>
               </a:rPr>
-              <a:t>Local convergence, section assumptions and material fatigue calibration limit physical conclusions. Unrecorded point histories remain unavailable.</a:t>
+              <a:t>The indices screen nominal stress cycles. Peak-range coverage does not prove cumulative-index convergence. Experimental validation and material fatigue calibration remain open.</a:t>
             </a:r>
           </a:p>
         </p:txBody>
       </p:sp>
       <p:sp>
         <p:nvSpPr>
-          <p:cNvPr id="35" name="">
+          <p:cNvPr id="34" name="">
             <a:extLst xmlns:a="http://schemas.openxmlformats.org/drawingml/2006/main">
               <a:ext uri="{FF2B5EF4-FFF2-40B4-BE49-F238E27FC236}">
                 <a16:creationId xmlns:a16="http://schemas.microsoft.com/office/drawing/2014/main" id="{B1A1EE30-C72D-4166-8504-9683C2F2FE80}"/>
@@ -7996,7 +7996,7 @@
       </p:sp>
       <p:sp>
         <p:nvSpPr>
-          <p:cNvPr id="36" name="ownership">
+          <p:cNvPr id="35" name="ownership">
             <a:extLst xmlns:a="http://schemas.openxmlformats.org/drawingml/2006/main">
               <a:ext uri="{FF2B5EF4-FFF2-40B4-BE49-F238E27FC236}">
                 <a16:creationId xmlns:a16="http://schemas.microsoft.com/office/drawing/2014/main" id="{D373DE15-49A1-4483-BE67-F96C4C1CEB83}"/>
@@ -8147,14 +8147,14 @@
                 <a:ea typeface="Arial"/>
                 <a:cs typeface="Arial"/>
               </a:rPr>
-              <a:t>Individual work: model reconstruction, implementation, verification, simulation review and documentation. Professor Zhang supplied the bridge drawings.</a:t>
+              <a:t>Individual work: model reconstruction, implementation, verification, simulation review and documentation. Professor Kai-Chun Chang supplied the bridge drawings.</a:t>
             </a:r>
           </a:p>
         </p:txBody>
       </p:sp>
       <p:sp>
         <p:nvSpPr>
-          <p:cNvPr id="37" name="scope">
+          <p:cNvPr id="36" name="scope">
             <a:extLst xmlns:a="http://schemas.openxmlformats.org/drawingml/2006/main">
               <a:ext uri="{FF2B5EF4-FFF2-40B4-BE49-F238E27FC236}">
                 <a16:creationId xmlns:a16="http://schemas.microsoft.com/office/drawing/2014/main" id="{05499B93-A2C8-4629-BA3B-08488554D6EB}"/>
@@ -8310,6 +8310,28 @@
           </a:p>
         </p:txBody>
       </p:sp>
+      <p:graphicFrame>
+        <p:nvGraphicFramePr>
+          <p:cNvPr id="37" name="Chart">
+            <a:extLst xmlns:a="http://schemas.openxmlformats.org/drawingml/2006/main">
+              <a:ext uri="{FF2B5EF4-FFF2-40B4-BE49-F238E27FC236}">
+                <a16:creationId xmlns:a16="http://schemas.microsoft.com/office/drawing/2014/main" id="{3EE9DB1C-635A-484F-9A4D-68FB20B60426}"/>
+              </a:ext>
+            </a:extLst>
+          </p:cNvPr>
+          <p:cNvGraphicFramePr/>
+          <p:nvPr/>
+        </p:nvGraphicFramePr>
+        <p:xfrm>
+          <a:off xmlns:a="http://schemas.openxmlformats.org/drawingml/2006/main" x="5166000" y="4645200"/>
+          <a:ext xmlns:a="http://schemas.openxmlformats.org/drawingml/2006/main" cx="4746000" cy="2688000"/>
+        </p:xfrm>
+        <a:graphic xmlns:a="http://schemas.openxmlformats.org/drawingml/2006/main">
+          <a:graphicData uri="http://schemas.openxmlformats.org/drawingml/2006/chart">
+            <c:chart xmlns:r="http://schemas.openxmlformats.org/officeDocument/2006/relationships" xmlns:c="http://schemas.openxmlformats.org/drawingml/2006/chart" r:id="R7d7ec474c433430b"/>
+          </a:graphicData>
+        </a:graphic>
+      </p:graphicFrame>
     </p:spTree>
     <p:extLst>
       <p:ext uri="{BB962C8B-B14F-4D97-AF65-F5344CB8AC3E}">

</xml_diff>

<commit_message>
Vehicle–bridge interaction and concrete deck fatigue assessment
Numerical fatigue performance across 22 traffic scenarios with a fixed
240-vehicle fleet. Concrete compression-fatigue damage, tensile-threshold
exceedances, stress recovery and assessment coverage.
</commit_message>
<xml_diff>
--- a/poster/VBI_research_poster.pptx
+++ b/poster/VBI_research_poster.pptx
@@ -2,13 +2,13 @@
 <file path=ppt/presentation.xml><?xml version="1.0" encoding="utf-8"?>
 <p:presentation xmlns:p="http://schemas.openxmlformats.org/presentationml/2006/main">
   <p:sldMasterIdLst>
-    <p:sldMasterId xmlns:r="http://schemas.openxmlformats.org/officeDocument/2006/relationships" id="2147483648" r:id="Rd73bd28226974d21"/>
+    <p:sldMasterId xmlns:r="http://schemas.openxmlformats.org/officeDocument/2006/relationships" id="2147483648" r:id="R6cc22657bf7a4640"/>
   </p:sldMasterIdLst>
   <p:notesMasterIdLst>
-    <p:notesMasterId xmlns:r="http://schemas.openxmlformats.org/officeDocument/2006/relationships" r:id="R1a22fde77ddc4359"/>
+    <p:notesMasterId xmlns:r="http://schemas.openxmlformats.org/officeDocument/2006/relationships" r:id="R535b03b4c13e42b1"/>
   </p:notesMasterIdLst>
   <p:sldIdLst>
-    <p:sldId xmlns:r="http://schemas.openxmlformats.org/officeDocument/2006/relationships" id="256" r:id="R87ef4927cd6a4efc"/>
+    <p:sldId xmlns:r="http://schemas.openxmlformats.org/officeDocument/2006/relationships" id="256" r:id="R2bfe837c92e547b5"/>
   </p:sldIdLst>
   <p:sldSz cx="15120000" cy="10692000"/>
   <p:notesSz cx="6858000" cy="9144000"/>
@@ -442,7 +442,7 @@
           <a:lstStyle xmlns:a="http://schemas.openxmlformats.org/drawingml/2006/main"/>
           <a:p xmlns:a="http://schemas.openxmlformats.org/drawingml/2006/main">
             <a:r>
-              <a:t>Sources: final 22-case nominal concrete stress-cycle screening and peak-range coverage summary, October 2026. The displayed 40 m reference-spacing cases use a matched passage-duration comparison. Rm is the ratio of case-wise maximum fixed-probe cumulative indices to the two-lane reference. The numerator and denominator may control at different locations. Minimum longitudinal/transverse peak-range coverage across all selected cases is 0.9553191368105968. The nominal stress screening uses uncracked gross-section recovery, separate from the section-recovery implementation checks. Professor Kai-Chun Chang provided the bridge drawings and reference materials. No private framework source code, source drawings or raw results are embedded.</a:t>
+              <a:t>Research sources: nominal reinforced-section concrete surface stresses, common-location compression-fatigue results, tensile-threshold exceedance counts and stress-range upper-bound coverage, October 2026. The displayed five protocols have matched 40 m reference spacing and passage duration. Damage D=sum n_i/N_i uses the adopted compression S-N model, K=17, fd=24/1.3 MPa, permanent stress baseline zero, and traffic-load increments. The full spectrum and 0.1 MPa range cutoff are sensitivity settings. The common compression pool excludes points with tensile exceedance in any case. All controlling damage comes from continuation beyond two million cycles. Grouped traffic has three exceeding locations and seven point episodes; episodes are not vehicles, rainflow cycles or simulated cracks. Minimum stress-range to full-field range-upper-bound coverage is 98.525583843414 percent, not exact full-field history coverage or damage convergence. Professor Kai-Chun Chang provided the drawings and reference materials. No private implementation or source documents are embedded.</a:t>
             </a:r>
           </a:p>
         </p:txBody>
@@ -2885,12 +2885,12 @@
   </p:cSld>
   <p:clrMap bg1="lt1" tx1="dk1" bg2="lt2" tx2="dk2" accent1="accent1" accent2="accent2" accent3="accent3" accent4="accent4" accent5="accent5" accent6="accent6" hlink="hlink" folHlink="folHlink"/>
   <p:sldLayoutIdLst>
-    <p:sldLayoutId xmlns:r="http://schemas.openxmlformats.org/officeDocument/2006/relationships" id="2147483649" r:id="Rcbdbd256160d4b3e"/>
-    <p:sldLayoutId xmlns:r="http://schemas.openxmlformats.org/officeDocument/2006/relationships" id="2147483650" r:id="Rcb032af800a743e0"/>
-    <p:sldLayoutId xmlns:r="http://schemas.openxmlformats.org/officeDocument/2006/relationships" id="2147483651" r:id="R9d1d5501723c4fde"/>
-    <p:sldLayoutId xmlns:r="http://schemas.openxmlformats.org/officeDocument/2006/relationships" id="2147483652" r:id="Rc4b19b37a7da4cda"/>
-    <p:sldLayoutId xmlns:r="http://schemas.openxmlformats.org/officeDocument/2006/relationships" id="2147483653" r:id="R0c34d17cd89b4c11"/>
-    <p:sldLayoutId xmlns:r="http://schemas.openxmlformats.org/officeDocument/2006/relationships" id="2147483654" r:id="R208547592d414de0"/>
+    <p:sldLayoutId xmlns:r="http://schemas.openxmlformats.org/officeDocument/2006/relationships" id="2147483649" r:id="R6c665764571147c3"/>
+    <p:sldLayoutId xmlns:r="http://schemas.openxmlformats.org/officeDocument/2006/relationships" id="2147483650" r:id="Rf46b63c55e124087"/>
+    <p:sldLayoutId xmlns:r="http://schemas.openxmlformats.org/officeDocument/2006/relationships" id="2147483651" r:id="R8d39f591e4d94184"/>
+    <p:sldLayoutId xmlns:r="http://schemas.openxmlformats.org/officeDocument/2006/relationships" id="2147483652" r:id="R95609df587cb4f23"/>
+    <p:sldLayoutId xmlns:r="http://schemas.openxmlformats.org/officeDocument/2006/relationships" id="2147483653" r:id="R4190b85ed9424a9b"/>
+    <p:sldLayoutId xmlns:r="http://schemas.openxmlformats.org/officeDocument/2006/relationships" id="2147483654" r:id="Rb52c0fdd744346be"/>
   </p:sldLayoutIdLst>
   <p:txStyles>
     <p:titleStyle>
@@ -3430,7 +3430,7 @@
           <c:idx val="0"/>
           <c:order val="0"/>
           <c:tx>
-            <c:v>R3</c:v>
+            <c:v>Full spectrum</c:v>
           </c:tx>
           <c:spPr>
             <a:solidFill xmlns:a="http://schemas.openxmlformats.org/drawingml/2006/main">
@@ -3468,19 +3468,19 @@
                 <c:formatCode>0</c:formatCode>
                 <c:ptCount val="5"/>
                 <c:pt idx="0">
-                  <c:v>1</c:v>
+                  <c:v>9.593192</c:v>
                 </c:pt>
                 <c:pt idx="1">
-                  <c:v>1.790525</c:v>
+                  <c:v>11.946461</c:v>
                 </c:pt>
                 <c:pt idx="2">
-                  <c:v>1.077521</c:v>
+                  <c:v>10.191177</c:v>
                 </c:pt>
                 <c:pt idx="3">
-                  <c:v>0.679234</c:v>
+                  <c:v>9.351135</c:v>
                 </c:pt>
                 <c:pt idx="4">
-                  <c:v>1.664541</c:v>
+                  <c:v>5.28235</c:v>
                 </c:pt>
               </c:numCache>
             </c:numRef>
@@ -3490,7 +3490,7 @@
           <c:idx val="1"/>
           <c:order val="1"/>
           <c:tx>
-            <c:v>R5</c:v>
+            <c:v>Range ≥0.1 MPa</c:v>
           </c:tx>
           <c:spPr>
             <a:solidFill xmlns:a="http://schemas.openxmlformats.org/drawingml/2006/main">
@@ -3528,19 +3528,19 @@
                 <c:formatCode>0</c:formatCode>
                 <c:ptCount val="5"/>
                 <c:pt idx="0">
-                  <c:v>1</c:v>
+                  <c:v>0.297826</c:v>
                 </c:pt>
                 <c:pt idx="1">
-                  <c:v>2.666752</c:v>
+                  <c:v>0.941048</c:v>
                 </c:pt>
                 <c:pt idx="2">
-                  <c:v>1.54677</c:v>
+                  <c:v>0.711459</c:v>
                 </c:pt>
                 <c:pt idx="3">
-                  <c:v>1.556537</c:v>
+                  <c:v>0.459089</c:v>
                 </c:pt>
                 <c:pt idx="4">
-                  <c:v>4.228691</c:v>
+                  <c:v>0.954587</c:v>
                 </c:pt>
               </c:numCache>
             </c:numRef>
@@ -3610,7 +3610,7 @@
         <c:axId val="48672768"/>
         <c:scaling>
           <c:orientation val="minMax"/>
-          <c:max val="5"/>
+          <c:max val="14"/>
           <c:min val="0"/>
         </c:scaling>
         <c:delete val="0"/>
@@ -3650,7 +3650,7 @@
         </c:txPr>
         <c:crossAx val="48650112"/>
         <c:crossBetween val="between"/>
-        <c:majorUnit val="1"/>
+        <c:majorUnit val="4"/>
       </c:valAx>
       <c:spPr>
         <a:solidFill xmlns:a="http://schemas.openxmlformats.org/drawingml/2006/main">
@@ -3666,7 +3666,7 @@
         <a:lstStyle xmlns:a="http://schemas.openxmlformats.org/drawingml/2006/main"/>
         <a:p xmlns:a="http://schemas.openxmlformats.org/drawingml/2006/main">
           <a:pPr>
-            <a:defRPr sz="1200">
+            <a:defRPr sz="1050">
               <a:solidFill>
                 <a:srgbClr val="243746"/>
               </a:solidFill>
@@ -4018,7 +4018,7 @@
                 <a:ea typeface="Arial"/>
                 <a:cs typeface="Arial"/>
               </a:rPr>
-              <a:t>Traffic Organization and Bridge Deck Response</a:t>
+              <a:t>Traffic Organization and Bridge Deck Fatigue</a:t>
             </a:r>
           </a:p>
         </p:txBody>
@@ -4176,7 +4176,7 @@
                 <a:ea typeface="Arial"/>
                 <a:cs typeface="Arial"/>
               </a:rPr>
-              <a:t>Traffic organization and nominal concrete stress cycles</a:t>
+              <a:t>Numerical fatigue performance under traffic loading</a:t>
             </a:r>
           </a:p>
         </p:txBody>
@@ -4731,7 +4731,7 @@
                 <a:ea typeface="Arial"/>
                 <a:cs typeface="Arial"/>
               </a:rPr>
-              <a:t>How does traffic organization affect local deck stress-cycle demand when the vehicle fleet stays fixed?</a:t>
+              <a:t>How does traffic organization influence concrete deck fatigue performance under the same vehicle fleet?</a:t>
             </a:r>
           </a:p>
         </p:txBody>
@@ -5969,7 +5969,7 @@
                 <a:ea typeface="Arial"/>
                 <a:cs typeface="Arial"/>
               </a:rPr>
-              <a:t>Traffic comparison</a:t>
+              <a:t>Compression fatigue</a:t>
             </a:r>
           </a:p>
         </p:txBody>
@@ -6156,7 +6156,7 @@
                 <a:ea typeface="Arial"/>
                 <a:cs typeface="Arial"/>
               </a:rPr>
-              <a:t>At d = 40 m, the fleet and passage duration match across the displayed protocols. Ratios compare maximum fixed-channel indices to two-lane traffic.</a:t>
+              <a:t>Cumulative damage D = Σ nᵢ/Nᵢ uses the adopted concrete compression S-N relationship. The same eligible observation locations define the comparison.</a:t>
             </a:r>
           </a:p>
         </p:txBody>
@@ -6314,7 +6314,7 @@
                 <a:ea typeface="Arial"/>
                 <a:cs typeface="Arial"/>
               </a:rPr>
-              <a:t>Relative cumulative index (two-lane = 1)</a:t>
+              <a:t>Maximum damage per 240 vehicles (×10⁻¹⁴)</a:t>
             </a:r>
           </a:p>
         </p:txBody>
@@ -6472,7 +6472,7 @@
                 <a:ea typeface="Arial"/>
                 <a:cs typeface="Arial"/>
               </a:rPr>
-              <a:t>Spread cases use uniform vehicle ordering. The maxima refer to fixed probes and may occur at different locations. Grouping changes the overall traffic organization.</a:t>
+              <a:t>d = 40 m, traffic increments, K = 17. The range cutoff tests sensitivity to small cycles. Tensile-exceedance locations remain outside the compression assessment.</a:t>
             </a:r>
           </a:p>
         </p:txBody>
@@ -6510,7 +6510,7 @@
           </a:bodyPr>
           <a:lstStyle xmlns:a="http://schemas.openxmlformats.org/drawingml/2006/main">
             <a:defPPr>
-              <a:defRPr sz="3373" b="1">
+              <a:defRPr sz="2513" b="1">
                 <a:solidFill>
                   <a:srgbClr val="087F8C"/>
                 </a:solidFill>
@@ -6520,7 +6520,7 @@
               </a:defRPr>
             </a:defPPr>
             <a:lvl1pPr>
-              <a:defRPr sz="3373" b="1">
+              <a:defRPr sz="2513" b="1">
                 <a:solidFill>
                   <a:srgbClr val="087F8C"/>
                 </a:solidFill>
@@ -6530,7 +6530,7 @@
               </a:defRPr>
             </a:lvl1pPr>
             <a:lvl2pPr>
-              <a:defRPr sz="3373" b="1">
+              <a:defRPr sz="2513" b="1">
                 <a:solidFill>
                   <a:srgbClr val="087F8C"/>
                 </a:solidFill>
@@ -6540,7 +6540,7 @@
               </a:defRPr>
             </a:lvl2pPr>
             <a:lvl3pPr>
-              <a:defRPr sz="3373" b="1">
+              <a:defRPr sz="2513" b="1">
                 <a:solidFill>
                   <a:srgbClr val="087F8C"/>
                 </a:solidFill>
@@ -6550,7 +6550,7 @@
               </a:defRPr>
             </a:lvl3pPr>
             <a:lvl4pPr>
-              <a:defRPr sz="3373" b="1">
+              <a:defRPr sz="2513" b="1">
                 <a:solidFill>
                   <a:srgbClr val="087F8C"/>
                 </a:solidFill>
@@ -6560,7 +6560,7 @@
               </a:defRPr>
             </a:lvl4pPr>
             <a:lvl5pPr>
-              <a:defRPr sz="3373" b="1">
+              <a:defRPr sz="2513" b="1">
                 <a:solidFill>
                   <a:srgbClr val="087F8C"/>
                 </a:solidFill>
@@ -6570,7 +6570,7 @@
               </a:defRPr>
             </a:lvl5pPr>
             <a:lvl6pPr>
-              <a:defRPr sz="3373" b="1">
+              <a:defRPr sz="2513" b="1">
                 <a:solidFill>
                   <a:srgbClr val="087F8C"/>
                 </a:solidFill>
@@ -6580,7 +6580,7 @@
               </a:defRPr>
             </a:lvl6pPr>
             <a:lvl7pPr>
-              <a:defRPr sz="3373" b="1">
+              <a:defRPr sz="2513" b="1">
                 <a:solidFill>
                   <a:srgbClr val="087F8C"/>
                 </a:solidFill>
@@ -6590,7 +6590,7 @@
               </a:defRPr>
             </a:lvl7pPr>
             <a:lvl8pPr>
-              <a:defRPr sz="3373" b="1">
+              <a:defRPr sz="2513" b="1">
                 <a:solidFill>
                   <a:srgbClr val="087F8C"/>
                 </a:solidFill>
@@ -6600,7 +6600,7 @@
               </a:defRPr>
             </a:lvl8pPr>
             <a:lvl9pPr>
-              <a:defRPr sz="3373" b="1">
+              <a:defRPr sz="2513" b="1">
                 <a:solidFill>
                   <a:srgbClr val="087F8C"/>
                 </a:solidFill>
@@ -6622,7 +6622,7 @@
               </a:defRPr>
             </a:pPr>
             <a:r>
-              <a:rPr sz="3373" b="1">
+              <a:rPr sz="2513" b="1">
                 <a:solidFill>
                   <a:srgbClr val="087F8C"/>
                 </a:solidFill>
@@ -6630,7 +6630,7 @@
                 <a:ea typeface="Arial"/>
                 <a:cs typeface="Arial"/>
               </a:rPr>
-              <a:t>95.53%</a:t>
+              <a:t>3 locations / 7 episodes</a:t>
             </a:r>
           </a:p>
         </p:txBody>
@@ -6788,7 +6788,7 @@
                 <a:ea typeface="Arial"/>
                 <a:cs typeface="Arial"/>
               </a:rPr>
-              <a:t>Minimum peak-range coverage across all 22 traffic scenarios, using both normal-stress directions.</a:t>
+              <a:t>Grouped traffic exceeds the tensile threshold at three common observation points.</a:t>
             </a:r>
           </a:p>
         </p:txBody>
@@ -6946,7 +6946,7 @@
                 <a:ea typeface="Arial"/>
                 <a:cs typeface="Arial"/>
               </a:rPr>
-              <a:t>Response coverage</a:t>
+              <a:t>Stress-range coverage</a:t>
             </a:r>
           </a:p>
         </p:txBody>
@@ -7133,7 +7133,7 @@
                 <a:ea typeface="Arial"/>
                 <a:cs typeface="Arial"/>
               </a:rPr>
-              <a:t>Coverage compares the largest saved rainflow range with the interior plate-field temporal range. The lower longitudinal/transverse ratio defines each case.</a:t>
+              <a:t>Nominal sections cover all saved observation coordinates.</a:t>
             </a:r>
           </a:p>
           <a:p xmlns:a="http://schemas.openxmlformats.org/drawingml/2006/main">
@@ -7171,7 +7171,7 @@
                 <a:ea typeface="Arial"/>
                 <a:cs typeface="Arial"/>
               </a:rPr>
-              <a:t>All 22 cases reach at least 95.53%.</a:t>
+              <a:t>Recorded stress ranges reach at least 98.53% of the interior field-range upper bound. This measures range-to-bound coverage.</a:t>
             </a:r>
           </a:p>
         </p:txBody>
@@ -7329,7 +7329,7 @@
                 <a:ea typeface="Arial"/>
                 <a:cs typeface="Arial"/>
               </a:rPr>
-              <a:t>Section recovery</a:t>
+              <a:t>Numerical checks</a:t>
             </a:r>
           </a:p>
         </p:txBody>
@@ -7516,7 +7516,7 @@
                 <a:ea typeface="Arial"/>
                 <a:cs typeface="Arial"/>
               </a:rPr>
-              <a:t>Nominal reinforcement sections cover the saved observation coordinates.</a:t>
+              <a:t>3,808 independent section-resultant checks and 23,680 cycle/parameter recomputations verify the implementation.</a:t>
             </a:r>
           </a:p>
           <a:p xmlns:a="http://schemas.openxmlformats.org/drawingml/2006/main">
@@ -7554,7 +7554,7 @@
                 <a:ea typeface="Arial"/>
                 <a:cs typeface="Arial"/>
               </a:rPr>
-              <a:t>952 section variants and 3,808 independent unit-resultant checks give a maximum residual of 1.1 × 10⁻¹⁴.</a:t>
+              <a:t>The maximum relative error in recalculating damage is 8.6 × 10⁻¹⁵.</a:t>
             </a:r>
           </a:p>
         </p:txBody>
@@ -7712,7 +7712,7 @@
                 <a:ea typeface="Arial"/>
                 <a:cs typeface="Arial"/>
               </a:rPr>
-              <a:t>Interpretation</a:t>
+              <a:t>Fatigue interpretation</a:t>
             </a:r>
           </a:p>
         </p:txBody>
@@ -7899,7 +7899,7 @@
                 <a:ea typeface="Arial"/>
                 <a:cs typeface="Arial"/>
               </a:rPr>
-              <a:t>Rₘ = max Iₘ(case) / max Iₘ(reference)</a:t>
+              <a:t>nᵢ: counted cycles</a:t>
             </a:r>
           </a:p>
           <a:p xmlns:a="http://schemas.openxmlformats.org/drawingml/2006/main">
@@ -7914,7 +7914,7 @@
               </a:defRPr>
             </a:pPr>
             <a:r>
-              <a:t>Iₘ = Σ nᵢ (Δσᵢ / 1 MPa)ᵐ</a:t>
+              <a:t>Nᵢ: cycles from the adopted S-N model</a:t>
             </a:r>
           </a:p>
           <a:p xmlns:a="http://schemas.openxmlformats.org/drawingml/2006/main">
@@ -7960,7 +7960,7 @@
                 <a:ea typeface="Arial"/>
                 <a:cs typeface="Arial"/>
               </a:rPr>
-              <a:t>The indices screen nominal stress cycles. Peak-range coverage does not prove cumulative-index convergence. Experimental validation and material fatigue calibration remain open.</a:t>
+              <a:t>Controlling damage uses S-N continuation beyond two million cycles. Small-cycle treatment affects comparisons. Tensile exceedance remains a separate outcome.</a:t>
             </a:r>
           </a:p>
         </p:txBody>
@@ -8305,7 +8305,7 @@
                 <a:ea typeface="Arial"/>
                 <a:cs typeface="Arial"/>
               </a:rPr>
-              <a:t>Preliminary numerical case study. Private framework and source drawings excluded. Experimental validation and absolute fatigue life remain open.</a:t>
+              <a:t>Conditional numerical fatigue assessment. Loading, S-N continuation and cycle-cutoff assumptions limit interpretation. No actual service-life prediction.</a:t>
             </a:r>
           </a:p>
         </p:txBody>
@@ -8315,7 +8315,7 @@
           <p:cNvPr id="37" name="Chart">
             <a:extLst xmlns:a="http://schemas.openxmlformats.org/drawingml/2006/main">
               <a:ext uri="{FF2B5EF4-FFF2-40B4-BE49-F238E27FC236}">
-                <a16:creationId xmlns:a16="http://schemas.microsoft.com/office/drawing/2014/main" id="{3EE9DB1C-635A-484F-9A4D-68FB20B60426}"/>
+                <a16:creationId xmlns:a16="http://schemas.microsoft.com/office/drawing/2014/main" id="{40C3362B-52A8-4203-B284-D6FA5E8060BA}"/>
               </a:ext>
             </a:extLst>
           </p:cNvPr>
@@ -8328,7 +8328,7 @@
         </p:xfrm>
         <a:graphic xmlns:a="http://schemas.openxmlformats.org/drawingml/2006/main">
           <a:graphicData uri="http://schemas.openxmlformats.org/drawingml/2006/chart">
-            <c:chart xmlns:r="http://schemas.openxmlformats.org/officeDocument/2006/relationships" xmlns:c="http://schemas.openxmlformats.org/drawingml/2006/chart" r:id="R7d7ec474c433430b"/>
+            <c:chart xmlns:r="http://schemas.openxmlformats.org/officeDocument/2006/relationships" xmlns:c="http://schemas.openxmlformats.org/drawingml/2006/chart" r:id="R80a973d90f73405b"/>
           </a:graphicData>
         </a:graphic>
       </p:graphicFrame>

</xml_diff>

<commit_message>
Concrete Bridge Deck and Slab Fatigue under Lane-Free Traffic
Assessment Using a Vehicle–Bridge Interaction Framework
</commit_message>
<xml_diff>
--- a/poster/VBI_research_poster.pptx
+++ b/poster/VBI_research_poster.pptx
@@ -2,13 +2,13 @@
 <file path=ppt/presentation.xml><?xml version="1.0" encoding="utf-8"?>
 <p:presentation xmlns:p="http://schemas.openxmlformats.org/presentationml/2006/main">
   <p:sldMasterIdLst>
-    <p:sldMasterId xmlns:r="http://schemas.openxmlformats.org/officeDocument/2006/relationships" id="2147483648" r:id="R6cc22657bf7a4640"/>
+    <p:sldMasterId xmlns:r="http://schemas.openxmlformats.org/officeDocument/2006/relationships" id="2147483648" r:id="R5862051b83a44c77"/>
   </p:sldMasterIdLst>
   <p:notesMasterIdLst>
-    <p:notesMasterId xmlns:r="http://schemas.openxmlformats.org/officeDocument/2006/relationships" r:id="R535b03b4c13e42b1"/>
+    <p:notesMasterId xmlns:r="http://schemas.openxmlformats.org/officeDocument/2006/relationships" r:id="R0ec45f91f4554513"/>
   </p:notesMasterIdLst>
   <p:sldIdLst>
-    <p:sldId xmlns:r="http://schemas.openxmlformats.org/officeDocument/2006/relationships" id="256" r:id="R2bfe837c92e547b5"/>
+    <p:sldId xmlns:r="http://schemas.openxmlformats.org/officeDocument/2006/relationships" id="256" r:id="Rb0c2b6a0e91947f9"/>
   </p:sldIdLst>
   <p:sldSz cx="15120000" cy="10692000"/>
   <p:notesSz cx="6858000" cy="9144000"/>
@@ -2885,12 +2885,12 @@
   </p:cSld>
   <p:clrMap bg1="lt1" tx1="dk1" bg2="lt2" tx2="dk2" accent1="accent1" accent2="accent2" accent3="accent3" accent4="accent4" accent5="accent5" accent6="accent6" hlink="hlink" folHlink="folHlink"/>
   <p:sldLayoutIdLst>
-    <p:sldLayoutId xmlns:r="http://schemas.openxmlformats.org/officeDocument/2006/relationships" id="2147483649" r:id="R6c665764571147c3"/>
-    <p:sldLayoutId xmlns:r="http://schemas.openxmlformats.org/officeDocument/2006/relationships" id="2147483650" r:id="Rf46b63c55e124087"/>
-    <p:sldLayoutId xmlns:r="http://schemas.openxmlformats.org/officeDocument/2006/relationships" id="2147483651" r:id="R8d39f591e4d94184"/>
-    <p:sldLayoutId xmlns:r="http://schemas.openxmlformats.org/officeDocument/2006/relationships" id="2147483652" r:id="R95609df587cb4f23"/>
-    <p:sldLayoutId xmlns:r="http://schemas.openxmlformats.org/officeDocument/2006/relationships" id="2147483653" r:id="R4190b85ed9424a9b"/>
-    <p:sldLayoutId xmlns:r="http://schemas.openxmlformats.org/officeDocument/2006/relationships" id="2147483654" r:id="Rb52c0fdd744346be"/>
+    <p:sldLayoutId xmlns:r="http://schemas.openxmlformats.org/officeDocument/2006/relationships" id="2147483649" r:id="Ra404fd37c24c4cff"/>
+    <p:sldLayoutId xmlns:r="http://schemas.openxmlformats.org/officeDocument/2006/relationships" id="2147483650" r:id="R421f1a0d64834526"/>
+    <p:sldLayoutId xmlns:r="http://schemas.openxmlformats.org/officeDocument/2006/relationships" id="2147483651" r:id="R6f7ff19c83254427"/>
+    <p:sldLayoutId xmlns:r="http://schemas.openxmlformats.org/officeDocument/2006/relationships" id="2147483652" r:id="R4c58f14ab51e49a6"/>
+    <p:sldLayoutId xmlns:r="http://schemas.openxmlformats.org/officeDocument/2006/relationships" id="2147483653" r:id="Rd53933ac0e0f4d8a"/>
+    <p:sldLayoutId xmlns:r="http://schemas.openxmlformats.org/officeDocument/2006/relationships" id="2147483654" r:id="Rbb6d8b3a65994d65"/>
   </p:sldLayoutIdLst>
   <p:txStyles>
     <p:titleStyle>
@@ -3898,7 +3898,7 @@
           </a:bodyPr>
           <a:lstStyle xmlns:a="http://schemas.openxmlformats.org/drawingml/2006/main">
             <a:defPPr>
-              <a:defRPr sz="3439" b="1">
+              <a:defRPr sz="2910" b="1">
                 <a:solidFill>
                   <a:srgbClr val="132B40"/>
                 </a:solidFill>
@@ -3908,7 +3908,7 @@
               </a:defRPr>
             </a:defPPr>
             <a:lvl1pPr>
-              <a:defRPr sz="3439" b="1">
+              <a:defRPr sz="2910" b="1">
                 <a:solidFill>
                   <a:srgbClr val="132B40"/>
                 </a:solidFill>
@@ -3918,7 +3918,7 @@
               </a:defRPr>
             </a:lvl1pPr>
             <a:lvl2pPr>
-              <a:defRPr sz="3439" b="1">
+              <a:defRPr sz="2910" b="1">
                 <a:solidFill>
                   <a:srgbClr val="132B40"/>
                 </a:solidFill>
@@ -3928,7 +3928,7 @@
               </a:defRPr>
             </a:lvl2pPr>
             <a:lvl3pPr>
-              <a:defRPr sz="3439" b="1">
+              <a:defRPr sz="2910" b="1">
                 <a:solidFill>
                   <a:srgbClr val="132B40"/>
                 </a:solidFill>
@@ -3938,7 +3938,7 @@
               </a:defRPr>
             </a:lvl3pPr>
             <a:lvl4pPr>
-              <a:defRPr sz="3439" b="1">
+              <a:defRPr sz="2910" b="1">
                 <a:solidFill>
                   <a:srgbClr val="132B40"/>
                 </a:solidFill>
@@ -3948,7 +3948,7 @@
               </a:defRPr>
             </a:lvl4pPr>
             <a:lvl5pPr>
-              <a:defRPr sz="3439" b="1">
+              <a:defRPr sz="2910" b="1">
                 <a:solidFill>
                   <a:srgbClr val="132B40"/>
                 </a:solidFill>
@@ -3958,7 +3958,7 @@
               </a:defRPr>
             </a:lvl5pPr>
             <a:lvl6pPr>
-              <a:defRPr sz="3439" b="1">
+              <a:defRPr sz="2910" b="1">
                 <a:solidFill>
                   <a:srgbClr val="132B40"/>
                 </a:solidFill>
@@ -3968,7 +3968,7 @@
               </a:defRPr>
             </a:lvl6pPr>
             <a:lvl7pPr>
-              <a:defRPr sz="3439" b="1">
+              <a:defRPr sz="2910" b="1">
                 <a:solidFill>
                   <a:srgbClr val="132B40"/>
                 </a:solidFill>
@@ -3978,7 +3978,7 @@
               </a:defRPr>
             </a:lvl7pPr>
             <a:lvl8pPr>
-              <a:defRPr sz="3439" b="1">
+              <a:defRPr sz="2910" b="1">
                 <a:solidFill>
                   <a:srgbClr val="132B40"/>
                 </a:solidFill>
@@ -3988,7 +3988,7 @@
               </a:defRPr>
             </a:lvl8pPr>
             <a:lvl9pPr>
-              <a:defRPr sz="3439" b="1">
+              <a:defRPr sz="2910" b="1">
                 <a:solidFill>
                   <a:srgbClr val="132B40"/>
                 </a:solidFill>
@@ -4010,7 +4010,7 @@
               </a:defRPr>
             </a:pPr>
             <a:r>
-              <a:rPr sz="3439" b="1">
+              <a:rPr sz="2910" b="1">
                 <a:solidFill>
                   <a:srgbClr val="132B40"/>
                 </a:solidFill>
@@ -4018,7 +4018,7 @@
                 <a:ea typeface="Arial"/>
                 <a:cs typeface="Arial"/>
               </a:rPr>
-              <a:t>Traffic Organization and Bridge Deck Fatigue</a:t>
+              <a:t>Concrete Bridge Deck and Slab Fatigue under Lane-Free Traffic</a:t>
             </a:r>
           </a:p>
         </p:txBody>
@@ -4176,7 +4176,7 @@
                 <a:ea typeface="Arial"/>
                 <a:cs typeface="Arial"/>
               </a:rPr>
-              <a:t>Numerical fatigue performance under traffic loading</a:t>
+              <a:t>Assessment Using a Vehicle–Bridge Interaction Framework</a:t>
             </a:r>
           </a:p>
         </p:txBody>
@@ -8328,7 +8328,7 @@
         </p:xfrm>
         <a:graphic xmlns:a="http://schemas.openxmlformats.org/drawingml/2006/main">
           <a:graphicData uri="http://schemas.openxmlformats.org/drawingml/2006/chart">
-            <c:chart xmlns:r="http://schemas.openxmlformats.org/officeDocument/2006/relationships" xmlns:c="http://schemas.openxmlformats.org/drawingml/2006/chart" r:id="R80a973d90f73405b"/>
+            <c:chart xmlns:r="http://schemas.openxmlformats.org/officeDocument/2006/relationships" xmlns:c="http://schemas.openxmlformats.org/drawingml/2006/chart" r:id="Rdbdacea688be403b"/>
           </a:graphicData>
         </a:graphic>
       </p:graphicFrame>

</xml_diff>